<commit_message>
docs: add brand logo guidelines, update README, and refine presentation assets
</commit_message>
<xml_diff>
--- a/author-profile.pptx
+++ b/author-profile.pptx
@@ -512,16 +512,7 @@
           <a:bodyPr/>
           <a:lstStyle/>
           <a:p>
-            <a:r>
-              <a:rPr lang="en-US" dirty="0"/>
-              <a:t>Sources: Shivam Singh resume variants: AI PMM, AI Product, Growth Marketing, Partner GTM, AI TPM, Strategy. Acronyms defined inline: GTM = go-to-market; PMF = product-market fit; PLG = product-led growth. Slide is designed as an executive spoken answer, not a prep-note checklist.</a:t>
-            </a:r>
-          </a:p>
-          <a:p>
-            <a:r>
-              <a:rPr lang="en-US"/>
-              <a:t>Spoken answer: I turn complex AI platforms into adoption across strategy, product, growth and enterprise GTM. Mistral Studio is the logical next step: it unites fast builder self-service with trusted enterprise production.</a:t>
-            </a:r>
+            <a:endParaRPr lang="en-US" dirty="0"/>
           </a:p>
         </p:txBody>
       </p:sp>
@@ -665,10 +656,7 @@
           <a:bodyPr/>
           <a:lstStyle/>
           <a:p>
-            <a:r>
-              <a:rPr lang="en-US" dirty="0"/>
-              <a:t>Sources: AI PMM resume for research-led repositioning, metrics and Japanese localization. AI Product / AI TPM resumes for RAG, evaluations, human-in-the-loop controls and guardrails.</a:t>
-            </a:r>
+            <a:endParaRPr lang="en-US" dirty="0"/>
           </a:p>
         </p:txBody>
       </p:sp>
@@ -812,10 +800,7 @@
           <a:bodyPr/>
           <a:lstStyle/>
           <a:p>
-            <a:r>
-              <a:rPr lang="en-US" dirty="0"/>
-              <a:t>Sources: AI PMM, AI Product, Partner GTM, Strategy and Investments resumes. PMF = product-market fit. Evidence includes 70+ business units, 50K+ merchants, buy-intelligence/build-context thesis, external foundation model, PII protection, hybrid retrieval, knowledge graph, standalone chatbot discontinuation, adoption/outcomes.</a:t>
-            </a:r>
+            <a:endParaRPr lang="en-US" dirty="0"/>
           </a:p>
         </p:txBody>
       </p:sp>
@@ -959,10 +944,7 @@
           <a:bodyPr/>
           <a:lstStyle/>
           <a:p>
-            <a:r>
-              <a:rPr lang="en-US" dirty="0"/>
-              <a:t>Sources: AI PMM, AI Product and Growth Marketing resumes. Acronyms defined inline: PLG = product-led growth; NRR = net revenue retention; ASO = App Store Optimization; RICE = reach, impact, confidence, effort. Evidence includes activation +262%, NRR 102%→128%, churn 14%→6.5%, win-back 4%→22%, lifecycle telemetry, time-to-first-value, cohort analysis, propensity models and campaign channels.</a:t>
-            </a:r>
+            <a:endParaRPr lang="en-US" dirty="0"/>
           </a:p>
         </p:txBody>
       </p:sp>
@@ -1106,10 +1088,7 @@
           <a:bodyPr/>
           <a:lstStyle/>
           <a:p>
-            <a:r>
-              <a:rPr lang="en-US" dirty="0"/>
-              <a:t>Sources: Partner GTM, AI TPM and FinTech Product resumes. FHE = fully homomorphic encryption. Evidence includes regulated customer objections, compliance-as-a-feature messaging, product/engineering/legal/field alignment, FHE→confidential computing pivot, latency 14s→220ms, SOPs across 10+ customer engagements, time-to-compliance 9→3 months, zero breaches, AI ROI +61%, $5M rescue and $2M upsell.</a:t>
-            </a:r>
+            <a:endParaRPr lang="en-US" dirty="0"/>
           </a:p>
         </p:txBody>
       </p:sp>
@@ -10618,7 +10597,7 @@
               <a:defRPr/>
             </a:pPr>
             <a:r>
-              <a:rPr kumimoji="0" lang="en-US" sz="1000" b="0" i="0" u="none" strike="noStrike" kern="1200" cap="none" spc="0" normalizeH="0" baseline="0" noProof="0">
+              <a:rPr kumimoji="0" lang="en-US" sz="1000" b="0" i="0" u="none" strike="noStrike" kern="1200" cap="none" spc="0" normalizeH="0" baseline="0" noProof="0" dirty="0">
                 <a:ln>
                   <a:noFill/>
                 </a:ln>
@@ -10632,7 +10611,7 @@
                 <a:ea typeface="+mn-ea"/>
                 <a:cs typeface="+mn-cs"/>
               </a:rPr>
-              <a:t>NRR = net revenue retention; activation = meaningful first value; churn = users leaving; win-back = returning lost users.</a:t>
+              <a:t>NRR = net revenue retention; activation = meaningful first value; win-back = returning lost users; ASO = App Store Optimization</a:t>
             </a:r>
           </a:p>
         </p:txBody>

</xml_diff>

<commit_message>
refactor(assets): update author profile and GTM launch strategy presentation decks
</commit_message>
<xml_diff>
--- a/author-profile.pptx
+++ b/author-profile.pptx
@@ -512,7 +512,210 @@
           <a:bodyPr/>
           <a:lstStyle/>
           <a:p>
+            <a:r>
+              <a:rPr lang="en-US" b="1" dirty="0"/>
+              <a:t>Tell me about yourself</a:t>
+            </a:r>
+          </a:p>
+          <a:p>
+            <a:pPr marL="0" marR="0" lvl="0" indent="0" algn="l" defTabSz="914400" rtl="0" eaLnBrk="1" fontAlgn="auto" latinLnBrk="0" hangingPunct="1">
+              <a:lnSpc>
+                <a:spcPct val="100000"/>
+              </a:lnSpc>
+              <a:spcBef>
+                <a:spcPts val="0"/>
+              </a:spcBef>
+              <a:spcAft>
+                <a:spcPts val="0"/>
+              </a:spcAft>
+              <a:buClrTx/>
+              <a:buSzTx/>
+              <a:buFontTx/>
+              <a:buNone/>
+              <a:tabLst/>
+              <a:defRPr/>
+            </a:pPr>
+            <a:r>
+              <a:rPr lang="en-US" dirty="0"/>
+              <a:t>My background sits at the intersection of AI, product and go-to-market. I've spent ten years making complex, regulated technology (AI and cloud capabilities) buyable(into products customers can understand, adopt and buy). </a:t>
+            </a:r>
+          </a:p>
+          <a:p>
+            <a:pPr marL="0" marR="0" lvl="0" indent="0" algn="l" defTabSz="914400" rtl="0" eaLnBrk="1" fontAlgn="auto" latinLnBrk="0" hangingPunct="1">
+              <a:lnSpc>
+                <a:spcPct val="100000"/>
+              </a:lnSpc>
+              <a:spcBef>
+                <a:spcPts val="0"/>
+              </a:spcBef>
+              <a:spcAft>
+                <a:spcPts val="0"/>
+              </a:spcAft>
+              <a:buClrTx/>
+              <a:buSzTx/>
+              <a:buFontTx/>
+              <a:buNone/>
+              <a:tabLst/>
+              <a:defRPr/>
+            </a:pPr>
             <a:endParaRPr lang="en-US" dirty="0"/>
+          </a:p>
+          <a:p>
+            <a:pPr marL="0" marR="0" lvl="0" indent="0" algn="l" defTabSz="914400" rtl="0" eaLnBrk="1" fontAlgn="auto" latinLnBrk="0" hangingPunct="1">
+              <a:lnSpc>
+                <a:spcPct val="100000"/>
+              </a:lnSpc>
+              <a:spcBef>
+                <a:spcPts val="0"/>
+              </a:spcBef>
+              <a:spcAft>
+                <a:spcPts val="0"/>
+              </a:spcAft>
+              <a:buClrTx/>
+              <a:buSzTx/>
+              <a:buFontTx/>
+              <a:buNone/>
+              <a:tabLst/>
+              <a:defRPr/>
+            </a:pPr>
+            <a:r>
+              <a:rPr lang="en-US" dirty="0"/>
+              <a:t>Mistral Studio is exactly that problem — the models are good; the job is making enterprise builders trust them enough to ship to production. Studio's opportunity is to turn Mistral from a model developers experiment with into the AI platform enterprises build and operate on.</a:t>
+            </a:r>
+            <a:endParaRPr lang="en-US" b="1" dirty="0"/>
+          </a:p>
+          <a:p>
+            <a:endParaRPr lang="en-US" b="1" dirty="0"/>
+          </a:p>
+          <a:p>
+            <a:r>
+              <a:rPr lang="en-US" b="1" dirty="0"/>
+              <a:t>Why Mistral?</a:t>
+            </a:r>
+          </a:p>
+          <a:p>
+            <a:r>
+              <a:rPr lang="en-US" dirty="0"/>
+              <a:t>AWS has given me tremendous exposure to scaling enterprise AI, but Mistral offers something different: the opportunity to shape the category narrative, at a company where product marketing can materially influence how the market understands the product.</a:t>
+            </a:r>
+            <a:endParaRPr lang="en-US" b="1" dirty="0"/>
+          </a:p>
+          <a:p>
+            <a:endParaRPr lang="en-US" dirty="0"/>
+          </a:p>
+          <a:p>
+            <a:pPr marL="0" marR="0" lvl="0" indent="0" algn="l" defTabSz="914400" rtl="0" eaLnBrk="1" fontAlgn="auto" latinLnBrk="0" hangingPunct="1">
+              <a:lnSpc>
+                <a:spcPct val="100000"/>
+              </a:lnSpc>
+              <a:spcBef>
+                <a:spcPts val="0"/>
+              </a:spcBef>
+              <a:spcAft>
+                <a:spcPts val="0"/>
+              </a:spcAft>
+              <a:buClrTx/>
+              <a:buSzTx/>
+              <a:buFontTx/>
+              <a:buNone/>
+              <a:tabLst/>
+              <a:defRPr/>
+            </a:pPr>
+            <a:r>
+              <a:rPr lang="en-US" b="1" dirty="0"/>
+              <a:t>One:</a:t>
+            </a:r>
+            <a:r>
+              <a:rPr lang="en-US" dirty="0"/>
+              <a:t> I've spent four years watching regulated buyers want frontier AI and be unable to legally deploy it. Mistral is the only credible answer for that buyer in Europe, and I've sold to that buyer at Microsoft and AWS. </a:t>
+            </a:r>
+          </a:p>
+          <a:p>
+            <a:pPr marL="0" marR="0" lvl="0" indent="0" algn="l" defTabSz="914400" rtl="0" eaLnBrk="1" fontAlgn="auto" latinLnBrk="0" hangingPunct="1">
+              <a:lnSpc>
+                <a:spcPct val="100000"/>
+              </a:lnSpc>
+              <a:spcBef>
+                <a:spcPts val="0"/>
+              </a:spcBef>
+              <a:spcAft>
+                <a:spcPts val="0"/>
+              </a:spcAft>
+              <a:buClrTx/>
+              <a:buSzTx/>
+              <a:buFontTx/>
+              <a:buNone/>
+              <a:tabLst/>
+              <a:defRPr/>
+            </a:pPr>
+            <a:r>
+              <a:rPr lang="en-US" b="1" dirty="0"/>
+              <a:t>Two:</a:t>
+            </a:r>
+            <a:r>
+              <a:rPr lang="en-US" dirty="0"/>
+              <a:t> the open-weight bet is about to be decided — the next 18 months determine whether enterprises standardize on rented APIs or owned models. </a:t>
+            </a:r>
+            <a:r>
+              <a:rPr lang="en-US" b="1" dirty="0"/>
+              <a:t>I'd rather be the person arguing the second case than the tenth PMM at a company arguing the first.</a:t>
+            </a:r>
+            <a:endParaRPr lang="en-US" dirty="0"/>
+          </a:p>
+          <a:p>
+            <a:endParaRPr lang="en-US" dirty="0"/>
+          </a:p>
+          <a:p>
+            <a:pPr marL="0" marR="0" lvl="0" indent="0" algn="l" defTabSz="914400" rtl="0" eaLnBrk="1" fontAlgn="auto" latinLnBrk="0" hangingPunct="1">
+              <a:lnSpc>
+                <a:spcPct val="100000"/>
+              </a:lnSpc>
+              <a:spcBef>
+                <a:spcPts val="0"/>
+              </a:spcBef>
+              <a:spcAft>
+                <a:spcPts val="0"/>
+              </a:spcAft>
+              <a:buClrTx/>
+              <a:buSzTx/>
+              <a:buFontTx/>
+              <a:buNone/>
+              <a:tabLst/>
+              <a:defRPr/>
+            </a:pPr>
+            <a:r>
+              <a:rPr lang="en-US" dirty="0"/>
+              <a:t>Mistral’s differentiation is bigger than model benchmarks. Mistral can offer enterprises much more control over how they build and deploy AI — particularly around sovereignty, deployment choice and open models. The PMM opportunity is to turn those technical advantages into a much simpler customer story: </a:t>
+            </a:r>
+            <a:r>
+              <a:rPr lang="en-US" b="1" dirty="0"/>
+              <a:t>why should an enterprise build and run production AI on Mistral rather than just consume another model API? </a:t>
+            </a:r>
+            <a:r>
+              <a:rPr lang="en-US" dirty="0"/>
+              <a:t>The interesting challenge with Studio is connecting the entire journey from developer experimentation to enterprise production. </a:t>
+            </a:r>
+          </a:p>
+          <a:p>
+            <a:endParaRPr lang="en-US" dirty="0"/>
+          </a:p>
+          <a:p>
+            <a:r>
+              <a:rPr lang="en-US" b="1" dirty="0"/>
+              <a:t>Questions</a:t>
+            </a:r>
+          </a:p>
+          <a:p>
+            <a:r>
+              <a:rPr lang="en-US" dirty="0"/>
+              <a:t>How is ownership divided between Studio product marketing, Developer Relations, solutions PMM and the GTM organization?</a:t>
+            </a:r>
+          </a:p>
+          <a:p>
+            <a:r>
+              <a:rPr lang="en-US" dirty="0"/>
+              <a:t>What is the biggest outcome Mistral wants this person to change — Studio's positioning, developer adoption, enterprise pipeline, or competitive win rate?</a:t>
+            </a:r>
           </a:p>
         </p:txBody>
       </p:sp>
@@ -656,7 +859,353 @@
           <a:bodyPr/>
           <a:lstStyle/>
           <a:p>
+            <a:pPr marL="0" marR="0" lvl="0" indent="0" algn="l" defTabSz="914400" rtl="0" eaLnBrk="1" fontAlgn="auto" latinLnBrk="0" hangingPunct="1">
+              <a:lnSpc>
+                <a:spcPct val="100000"/>
+              </a:lnSpc>
+              <a:spcBef>
+                <a:spcPts val="0"/>
+              </a:spcBef>
+              <a:spcAft>
+                <a:spcPts val="0"/>
+              </a:spcAft>
+              <a:buClrTx/>
+              <a:buSzTx/>
+              <a:buFontTx/>
+              <a:buNone/>
+              <a:tabLst/>
+              <a:defRPr/>
+            </a:pPr>
+            <a:r>
+              <a:rPr lang="en-US" b="1" dirty="0"/>
+              <a:t>Developer/platform PMM</a:t>
+            </a:r>
+            <a:r>
+              <a:rPr lang="en-US" dirty="0"/>
+              <a:t> — I ran positioning for a managed agent platform at AWS connecting foundation models to private enterprise data (access controls, audit traces, approvals, cost-quality routing). Where I use customer research and product telemetry to sharpen the positioning, build the launch and adoption strategy, and helped drive adoption while improving brand favorability. </a:t>
+            </a:r>
+          </a:p>
+          <a:p>
+            <a:pPr marL="0" marR="0" lvl="0" indent="0" algn="l" defTabSz="914400" rtl="0" eaLnBrk="1" fontAlgn="auto" latinLnBrk="0" hangingPunct="1">
+              <a:lnSpc>
+                <a:spcPct val="100000"/>
+              </a:lnSpc>
+              <a:spcBef>
+                <a:spcPts val="0"/>
+              </a:spcBef>
+              <a:spcAft>
+                <a:spcPts val="0"/>
+              </a:spcAft>
+              <a:buClrTx/>
+              <a:buSzTx/>
+              <a:buFontTx/>
+              <a:buNone/>
+              <a:tabLst/>
+              <a:defRPr/>
+            </a:pPr>
+            <a:endParaRPr lang="en-US" b="0" dirty="0"/>
+          </a:p>
+          <a:p>
+            <a:pPr marL="0" marR="0" lvl="0" indent="0" algn="l" defTabSz="914400" rtl="0" eaLnBrk="1" fontAlgn="auto" latinLnBrk="0" hangingPunct="1">
+              <a:lnSpc>
+                <a:spcPct val="100000"/>
+              </a:lnSpc>
+              <a:spcBef>
+                <a:spcPts val="0"/>
+              </a:spcBef>
+              <a:spcAft>
+                <a:spcPts val="0"/>
+              </a:spcAft>
+              <a:buClrTx/>
+              <a:buSzTx/>
+              <a:buFontTx/>
+              <a:buNone/>
+              <a:tabLst/>
+              <a:defRPr/>
+            </a:pPr>
+            <a:r>
+              <a:rPr lang="en-US" b="1" dirty="0"/>
+              <a:t>How do you market a technical product without hype?</a:t>
+            </a:r>
+            <a:br>
+              <a:rPr lang="en-US" dirty="0"/>
+            </a:br>
+            <a:r>
+              <a:rPr lang="en-US" dirty="0"/>
+              <a:t>At AWS I repositioned an AI shopping experience away from open-ended conversation toward decision support — that came from behavioral telemetry, not a brand workshop. I replace claims with </a:t>
+            </a:r>
+            <a:r>
+              <a:rPr lang="en-US" b="1" dirty="0"/>
+              <a:t>evidence artifacts</a:t>
+            </a:r>
+            <a:r>
+              <a:rPr lang="en-US" dirty="0"/>
+              <a:t>.</a:t>
+            </a:r>
+            <a:endParaRPr lang="en-US" b="0" dirty="0"/>
+          </a:p>
+          <a:p>
+            <a:pPr marL="0" marR="0" lvl="0" indent="0" algn="l" defTabSz="914400" rtl="0" eaLnBrk="1" fontAlgn="auto" latinLnBrk="0" hangingPunct="1">
+              <a:lnSpc>
+                <a:spcPct val="100000"/>
+              </a:lnSpc>
+              <a:spcBef>
+                <a:spcPts val="0"/>
+              </a:spcBef>
+              <a:spcAft>
+                <a:spcPts val="0"/>
+              </a:spcAft>
+              <a:buClrTx/>
+              <a:buSzTx/>
+              <a:buFontTx/>
+              <a:buNone/>
+              <a:tabLst/>
+              <a:defRPr/>
+            </a:pPr>
             <a:endParaRPr lang="en-US" dirty="0"/>
+          </a:p>
+          <a:p>
+            <a:pPr rtl="0"/>
+            <a:r>
+              <a:rPr lang="en-US" b="1" dirty="0"/>
+              <a:t>How do you measure PMM success?</a:t>
+            </a:r>
+            <a:br>
+              <a:rPr lang="en-US" dirty="0"/>
+            </a:br>
+            <a:r>
+              <a:rPr lang="en-US" dirty="0"/>
+              <a:t>Not MQLs. Three tiers:</a:t>
+            </a:r>
+          </a:p>
+          <a:p>
+            <a:pPr lvl="0" rtl="0"/>
+            <a:r>
+              <a:rPr lang="en-US" b="1" dirty="0"/>
+              <a:t>Leading:</a:t>
+            </a:r>
+            <a:r>
+              <a:rPr lang="en-US" dirty="0"/>
+              <a:t> message resonance in win/loss, docs-to-first-call conversion, sales objection frequency.</a:t>
+            </a:r>
+          </a:p>
+          <a:p>
+            <a:pPr lvl="0" rtl="0"/>
+            <a:r>
+              <a:rPr lang="en-US" b="1" dirty="0"/>
+              <a:t>Activation:</a:t>
+            </a:r>
+            <a:r>
+              <a:rPr lang="en-US" dirty="0"/>
+              <a:t> signup → </a:t>
+            </a:r>
+            <a:r>
+              <a:rPr lang="en-US" b="1" dirty="0"/>
+              <a:t>first production workload</a:t>
+            </a:r>
+            <a:r>
+              <a:rPr lang="en-US" dirty="0"/>
+              <a:t> (the number that actually matters for a dev platform).</a:t>
+            </a:r>
+          </a:p>
+          <a:p>
+            <a:pPr lvl="0" rtl="0"/>
+            <a:r>
+              <a:rPr lang="en-US" b="1" dirty="0"/>
+              <a:t>Commercial:</a:t>
+            </a:r>
+            <a:r>
+              <a:rPr lang="en-US" dirty="0"/>
+              <a:t> win rate vs named competitors, ACV mix, gross margin.</a:t>
+            </a:r>
+          </a:p>
+          <a:p>
+            <a:pPr lvl="0" rtl="0"/>
+            <a:br>
+              <a:rPr lang="en-US" dirty="0"/>
+            </a:br>
+            <a:r>
+              <a:rPr lang="en-US" dirty="0"/>
+              <a:t>At AWS I tied launch funding to milestone gates on adoption, trust, and unit economics — same discipline. </a:t>
+            </a:r>
+            <a:r>
+              <a:rPr lang="en-US" b="1" dirty="0"/>
+              <a:t>If I can't name the gate, I don't ship the launch.</a:t>
+            </a:r>
+            <a:endParaRPr lang="en-US" dirty="0"/>
+          </a:p>
+          <a:p>
+            <a:pPr marL="0" marR="0" lvl="0" indent="0" algn="l" defTabSz="914400" rtl="0" eaLnBrk="1" fontAlgn="auto" latinLnBrk="0" hangingPunct="1">
+              <a:lnSpc>
+                <a:spcPct val="100000"/>
+              </a:lnSpc>
+              <a:spcBef>
+                <a:spcPts val="0"/>
+              </a:spcBef>
+              <a:spcAft>
+                <a:spcPts val="0"/>
+              </a:spcAft>
+              <a:buClrTx/>
+              <a:buSzTx/>
+              <a:buFontTx/>
+              <a:buNone/>
+              <a:tabLst/>
+              <a:defRPr/>
+            </a:pPr>
+            <a:endParaRPr lang="en-US" dirty="0"/>
+          </a:p>
+          <a:p>
+            <a:pPr marL="0" marR="0" lvl="0" indent="0" algn="l" defTabSz="914400" rtl="0" eaLnBrk="1" fontAlgn="auto" latinLnBrk="0" hangingPunct="1">
+              <a:lnSpc>
+                <a:spcPct val="100000"/>
+              </a:lnSpc>
+              <a:spcBef>
+                <a:spcPts val="0"/>
+              </a:spcBef>
+              <a:spcAft>
+                <a:spcPts val="0"/>
+              </a:spcAft>
+              <a:buClrTx/>
+              <a:buSzTx/>
+              <a:buFontTx/>
+              <a:buNone/>
+              <a:tabLst/>
+              <a:defRPr/>
+            </a:pPr>
+            <a:r>
+              <a:rPr lang="en-US" b="1" dirty="0"/>
+              <a:t>How do you work with engineering/DevRel?</a:t>
+            </a:r>
+            <a:br>
+              <a:rPr lang="en-US" dirty="0"/>
+            </a:br>
+            <a:r>
+              <a:rPr lang="en-US" dirty="0"/>
+              <a:t>I bring the </a:t>
+            </a:r>
+            <a:r>
+              <a:rPr lang="en-US" b="1" dirty="0"/>
+              <a:t>launch-readiness bar</a:t>
+            </a:r>
+            <a:r>
+              <a:rPr lang="en-US" dirty="0"/>
+              <a:t>, they bring capability. I define gates — eval thresholds, guardrails, docs quality — so "launch" is a decision, not a vibe. That's how I got hallucinations to 2.8% before shipping.</a:t>
+            </a:r>
+          </a:p>
+          <a:p>
+            <a:pPr marL="0" marR="0" lvl="0" indent="0" algn="l" defTabSz="914400" rtl="0" eaLnBrk="1" fontAlgn="auto" latinLnBrk="0" hangingPunct="1">
+              <a:lnSpc>
+                <a:spcPct val="100000"/>
+              </a:lnSpc>
+              <a:spcBef>
+                <a:spcPts val="0"/>
+              </a:spcBef>
+              <a:spcAft>
+                <a:spcPts val="0"/>
+              </a:spcAft>
+              <a:buClrTx/>
+              <a:buSzTx/>
+              <a:buFontTx/>
+              <a:buNone/>
+              <a:tabLst/>
+              <a:defRPr/>
+            </a:pPr>
+            <a:r>
+              <a:rPr lang="en-US" dirty="0"/>
+              <a:t>What I'd carry over: </a:t>
+            </a:r>
+            <a:r>
+              <a:rPr lang="en-US" b="1" dirty="0"/>
+              <a:t>the launch-gate discipline.</a:t>
+            </a:r>
+            <a:r>
+              <a:rPr lang="en-US" dirty="0"/>
+              <a:t> Startups under-invest in it and it's the cheapest quality mechanism there is.</a:t>
+            </a:r>
+          </a:p>
+          <a:p>
+            <a:pPr marL="0" marR="0" lvl="0" indent="0" algn="l" defTabSz="914400" rtl="0" eaLnBrk="1" fontAlgn="auto" latinLnBrk="0" hangingPunct="1">
+              <a:lnSpc>
+                <a:spcPct val="100000"/>
+              </a:lnSpc>
+              <a:spcBef>
+                <a:spcPts val="0"/>
+              </a:spcBef>
+              <a:spcAft>
+                <a:spcPts val="0"/>
+              </a:spcAft>
+              <a:buClrTx/>
+              <a:buSzTx/>
+              <a:buFontTx/>
+              <a:buNone/>
+              <a:tabLst/>
+              <a:defRPr/>
+            </a:pPr>
+            <a:endParaRPr lang="en-US" dirty="0"/>
+          </a:p>
+          <a:p>
+            <a:pPr marL="0" marR="0" lvl="0" indent="0" algn="l" defTabSz="914400" rtl="0" eaLnBrk="1" fontAlgn="auto" latinLnBrk="0" hangingPunct="1">
+              <a:lnSpc>
+                <a:spcPct val="100000"/>
+              </a:lnSpc>
+              <a:spcBef>
+                <a:spcPts val="0"/>
+              </a:spcBef>
+              <a:spcAft>
+                <a:spcPts val="0"/>
+              </a:spcAft>
+              <a:buClrTx/>
+              <a:buSzTx/>
+              <a:buFontTx/>
+              <a:buNone/>
+              <a:tabLst/>
+              <a:defRPr/>
+            </a:pPr>
+            <a:r>
+              <a:rPr lang="en-US" b="1" dirty="0"/>
+              <a:t>Hardest launch you've run.</a:t>
+            </a:r>
+            <a:br>
+              <a:rPr lang="en-US" dirty="0"/>
+            </a:br>
+            <a:r>
+              <a:rPr lang="en-US" dirty="0"/>
+              <a:t>Japan localization at AWS. Not translation — tone, tokenization, honorifics, interaction design. I turned it into a </a:t>
+            </a:r>
+            <a:r>
+              <a:rPr lang="en-US" b="1" dirty="0"/>
+              <a:t>reusable internationalization template</a:t>
+            </a:r>
+            <a:r>
+              <a:rPr lang="en-US" dirty="0"/>
+              <a:t>, which is what Mistral needs going market by market across the EU and beyond.</a:t>
+            </a:r>
+          </a:p>
+          <a:p>
+            <a:pPr marL="0" marR="0" lvl="0" indent="0" algn="l" defTabSz="914400" rtl="0" eaLnBrk="1" fontAlgn="auto" latinLnBrk="0" hangingPunct="1">
+              <a:lnSpc>
+                <a:spcPct val="100000"/>
+              </a:lnSpc>
+              <a:spcBef>
+                <a:spcPts val="0"/>
+              </a:spcBef>
+              <a:spcAft>
+                <a:spcPts val="0"/>
+              </a:spcAft>
+              <a:buClrTx/>
+              <a:buSzTx/>
+              <a:buFontTx/>
+              <a:buNone/>
+              <a:tabLst/>
+              <a:defRPr/>
+            </a:pPr>
+            <a:endParaRPr lang="en-US" dirty="0"/>
+          </a:p>
+          <a:p>
+            <a:r>
+              <a:rPr lang="en-US" dirty="0"/>
+              <a:t>Customer problem → insight → positioning/GTM decision → measurable result.</a:t>
+            </a:r>
           </a:p>
         </p:txBody>
       </p:sp>
@@ -800,6 +1349,178 @@
           <a:bodyPr/>
           <a:lstStyle/>
           <a:p>
+            <a:pPr marL="0" marR="0" lvl="0" indent="0" algn="l" defTabSz="914400" rtl="0" eaLnBrk="1" fontAlgn="auto" latinLnBrk="0" hangingPunct="1">
+              <a:lnSpc>
+                <a:spcPct val="100000"/>
+              </a:lnSpc>
+              <a:spcBef>
+                <a:spcPts val="0"/>
+              </a:spcBef>
+              <a:spcAft>
+                <a:spcPts val="0"/>
+              </a:spcAft>
+              <a:buClrTx/>
+              <a:buSzTx/>
+              <a:buFontTx/>
+              <a:buNone/>
+              <a:tabLst/>
+              <a:defRPr/>
+            </a:pPr>
+            <a:r>
+              <a:rPr lang="en-US" dirty="0"/>
+              <a:t>Before that, at Rakuten I worked on an AI platform serving 50,000 merchants, where I increased conversion by Driving adoption and PMF</a:t>
+            </a:r>
+          </a:p>
+          <a:p>
+            <a:pPr marL="0" marR="0" lvl="0" indent="0" algn="l" defTabSz="914400" rtl="0" eaLnBrk="1" fontAlgn="auto" latinLnBrk="0" hangingPunct="1">
+              <a:lnSpc>
+                <a:spcPct val="100000"/>
+              </a:lnSpc>
+              <a:spcBef>
+                <a:spcPts val="0"/>
+              </a:spcBef>
+              <a:spcAft>
+                <a:spcPts val="0"/>
+              </a:spcAft>
+              <a:buClrTx/>
+              <a:buSzTx/>
+              <a:buFontTx/>
+              <a:buNone/>
+              <a:tabLst/>
+              <a:defRPr/>
+            </a:pPr>
+            <a:endParaRPr lang="en-US" dirty="0"/>
+          </a:p>
+          <a:p>
+            <a:pPr marL="0" marR="0" lvl="0" indent="0" algn="l" defTabSz="914400" rtl="0" eaLnBrk="1" fontAlgn="auto" latinLnBrk="0" hangingPunct="1">
+              <a:lnSpc>
+                <a:spcPct val="100000"/>
+              </a:lnSpc>
+              <a:spcBef>
+                <a:spcPts val="0"/>
+              </a:spcBef>
+              <a:spcAft>
+                <a:spcPts val="0"/>
+              </a:spcAft>
+              <a:buClrTx/>
+              <a:buSzTx/>
+              <a:buFontTx/>
+              <a:buNone/>
+              <a:tabLst/>
+              <a:defRPr/>
+            </a:pPr>
+            <a:r>
+              <a:rPr lang="en-US" b="1" dirty="0"/>
+              <a:t>Walk me through a piece of messaging you wrote that failed.</a:t>
+            </a:r>
+            <a:br>
+              <a:rPr lang="en-US" dirty="0"/>
+            </a:br>
+            <a:r>
+              <a:rPr lang="en-US" dirty="0"/>
+              <a:t>Framework: </a:t>
+            </a:r>
+            <a:r>
+              <a:rPr lang="en-US" b="1" dirty="0"/>
+              <a:t>Claim → Evidence gap → Rewrite.</a:t>
+            </a:r>
+            <a:r>
+              <a:rPr lang="en-US" dirty="0"/>
+              <a:t> </a:t>
+            </a:r>
+          </a:p>
+          <a:p>
+            <a:pPr marL="0" marR="0" lvl="0" indent="0" algn="l" defTabSz="914400" rtl="0" eaLnBrk="1" fontAlgn="auto" latinLnBrk="0" hangingPunct="1">
+              <a:lnSpc>
+                <a:spcPct val="100000"/>
+              </a:lnSpc>
+              <a:spcBef>
+                <a:spcPts val="0"/>
+              </a:spcBef>
+              <a:spcAft>
+                <a:spcPts val="0"/>
+              </a:spcAft>
+              <a:buClrTx/>
+              <a:buSzTx/>
+              <a:buFontTx/>
+              <a:buNone/>
+              <a:tabLst/>
+              <a:defRPr/>
+            </a:pPr>
+            <a:r>
+              <a:rPr lang="en-US" dirty="0"/>
+              <a:t>At Rakuten I launched a standalone merchant chatbot positioned on "AI assistant for your store." Adoption stalled — the message promised a companion, the product solved one task. </a:t>
+            </a:r>
+          </a:p>
+          <a:p>
+            <a:pPr marL="0" marR="0" lvl="0" indent="0" algn="l" defTabSz="914400" rtl="0" eaLnBrk="1" fontAlgn="auto" latinLnBrk="0" hangingPunct="1">
+              <a:lnSpc>
+                <a:spcPct val="100000"/>
+              </a:lnSpc>
+              <a:spcBef>
+                <a:spcPts val="0"/>
+              </a:spcBef>
+              <a:spcAft>
+                <a:spcPts val="0"/>
+              </a:spcAft>
+              <a:buClrTx/>
+              <a:buSzTx/>
+              <a:buFontTx/>
+              <a:buNone/>
+              <a:tabLst/>
+              <a:defRPr/>
+            </a:pPr>
+            <a:r>
+              <a:rPr lang="en-US" dirty="0"/>
+              <a:t>I killed it, re-anchored on </a:t>
+            </a:r>
+            <a:r>
+              <a:rPr lang="en-US" b="1" dirty="0"/>
+              <a:t>"list a product in 12 minutes instead of 45,"</a:t>
+            </a:r>
+            <a:r>
+              <a:rPr lang="en-US" dirty="0"/>
+              <a:t> and embedded AI into the existing workflow. Hit </a:t>
+            </a:r>
+            <a:r>
+              <a:rPr lang="en-US" b="1" dirty="0"/>
+              <a:t>40% adoption in six months, +15% conversion</a:t>
+            </a:r>
+            <a:r>
+              <a:rPr lang="en-US" dirty="0"/>
+              <a:t>. </a:t>
+            </a:r>
+          </a:p>
+          <a:p>
+            <a:pPr marL="0" marR="0" lvl="0" indent="0" algn="l" defTabSz="914400" rtl="0" eaLnBrk="1" fontAlgn="auto" latinLnBrk="0" hangingPunct="1">
+              <a:lnSpc>
+                <a:spcPct val="100000"/>
+              </a:lnSpc>
+              <a:spcBef>
+                <a:spcPts val="0"/>
+              </a:spcBef>
+              <a:spcAft>
+                <a:spcPts val="0"/>
+              </a:spcAft>
+              <a:buClrTx/>
+              <a:buSzTx/>
+              <a:buFontTx/>
+              <a:buNone/>
+              <a:tabLst/>
+              <a:defRPr/>
+            </a:pPr>
+            <a:r>
+              <a:rPr lang="en-US" dirty="0"/>
+              <a:t>Lesson: </a:t>
+            </a:r>
+            <a:r>
+              <a:rPr lang="en-US" b="1" dirty="0"/>
+              <a:t>positioning fails when the promise is broader than the </a:t>
+            </a:r>
+            <a:r>
+              <a:rPr lang="en-US" b="1"/>
+              <a:t>proof.</a:t>
+            </a:r>
             <a:endParaRPr lang="en-US" dirty="0"/>
           </a:p>
         </p:txBody>
@@ -944,7 +1665,36 @@
           <a:bodyPr/>
           <a:lstStyle/>
           <a:p>
+            <a:pPr marL="0" marR="0" lvl="0" indent="0" algn="l" defTabSz="914400" rtl="0" eaLnBrk="1" fontAlgn="auto" latinLnBrk="0" hangingPunct="1">
+              <a:lnSpc>
+                <a:spcPct val="100000"/>
+              </a:lnSpc>
+              <a:spcBef>
+                <a:spcPts val="0"/>
+              </a:spcBef>
+              <a:spcAft>
+                <a:spcPts val="0"/>
+              </a:spcAft>
+              <a:buClrTx/>
+              <a:buSzTx/>
+              <a:buFontTx/>
+              <a:buNone/>
+              <a:tabLst/>
+              <a:defRPr/>
+            </a:pPr>
+            <a:r>
+              <a:rPr lang="en-US" dirty="0"/>
+              <a:t>And at Microsoft, I worked on enterprise GTM and segmentation along with lifecycle growth.</a:t>
+            </a:r>
+          </a:p>
+          <a:p>
             <a:endParaRPr lang="en-US" dirty="0"/>
+          </a:p>
+          <a:p>
+            <a:r>
+              <a:rPr lang="en-US" dirty="0"/>
+              <a:t>Customer problem → insight → positioning/GTM decision → measurable result.</a:t>
+            </a:r>
           </a:p>
         </p:txBody>
       </p:sp>
@@ -1088,6 +1838,96 @@
           <a:bodyPr/>
           <a:lstStyle/>
           <a:p>
+            <a:pPr marL="0" marR="0" lvl="0" indent="0" algn="l" defTabSz="914400" rtl="0" eaLnBrk="1" fontAlgn="auto" latinLnBrk="0" hangingPunct="1">
+              <a:lnSpc>
+                <a:spcPct val="100000"/>
+              </a:lnSpc>
+              <a:spcBef>
+                <a:spcPts val="0"/>
+              </a:spcBef>
+              <a:spcAft>
+                <a:spcPts val="0"/>
+              </a:spcAft>
+              <a:buClrTx/>
+              <a:buSzTx/>
+              <a:buFontTx/>
+              <a:buNone/>
+              <a:tabLst/>
+              <a:defRPr/>
+            </a:pPr>
+            <a:r>
+              <a:rPr lang="en-US" b="1" dirty="0"/>
+              <a:t>Sovereignty is my wedge</a:t>
+            </a:r>
+            <a:r>
+              <a:rPr lang="en-US" dirty="0"/>
+              <a:t> — Mistral's differentiator is EU/on-prem control. I've sold that exact story: regulated-cloud deployment patterns across 10 markets, data residency, in-country key management, compliance-as-a-feature.</a:t>
+            </a:r>
+          </a:p>
+          <a:p>
+            <a:endParaRPr lang="en-US" dirty="0"/>
+          </a:p>
+          <a:p>
+            <a:r>
+              <a:rPr lang="en-US" b="1" dirty="0"/>
+              <a:t>How do you enable a sales team you don't manage?</a:t>
+            </a:r>
+            <a:endParaRPr lang="en-US" dirty="0"/>
+          </a:p>
+          <a:p>
+            <a:r>
+              <a:rPr lang="en-US" b="1" dirty="0"/>
+              <a:t>Three artifacts, in this order:</a:t>
+            </a:r>
+            <a:r>
+              <a:rPr lang="en-US" dirty="0"/>
+              <a:t> (a) the </a:t>
+            </a:r>
+            <a:r>
+              <a:rPr lang="en-US" b="1" dirty="0"/>
+              <a:t>objection map</a:t>
+            </a:r>
+            <a:r>
+              <a:rPr lang="en-US" dirty="0"/>
+              <a:t> — top 10 real objections from call recordings, each with a one-line answer and a proof link; (b) the </a:t>
+            </a:r>
+            <a:r>
+              <a:rPr lang="en-US" b="1" dirty="0"/>
+              <a:t>discovery question set</a:t>
+            </a:r>
+            <a:r>
+              <a:rPr lang="en-US" dirty="0"/>
+              <a:t> that qualifies for sovereignty need in the first call; (c) </a:t>
+            </a:r>
+            <a:r>
+              <a:rPr lang="en-US" b="1" dirty="0"/>
+              <a:t>one demo narrative</a:t>
+            </a:r>
+            <a:r>
+              <a:rPr lang="en-US" dirty="0"/>
+              <a:t>, not five. Then I measure </a:t>
+            </a:r>
+            <a:r>
+              <a:rPr lang="en-US" b="1" dirty="0"/>
+              <a:t>objection frequency over time</a:t>
+            </a:r>
+            <a:r>
+              <a:rPr lang="en-US" dirty="0"/>
+              <a:t> — if the same blocker keeps surfacing, my enablement failed, not the rep. </a:t>
+            </a:r>
+          </a:p>
+          <a:p>
+            <a:endParaRPr lang="en-US" dirty="0"/>
+          </a:p>
+          <a:p>
+            <a:r>
+              <a:rPr lang="en-US" dirty="0"/>
+              <a:t>At Microsoft this is how compliance-as-a-feature went from a blocker to the reason we </a:t>
+            </a:r>
+            <a:r>
+              <a:rPr lang="en-US" b="1" dirty="0"/>
+              <a:t>recovered a $5M account and won a $2M upsell.</a:t>
+            </a:r>
             <a:endParaRPr lang="en-US" dirty="0"/>
           </a:p>
         </p:txBody>

</xml_diff>